<commit_message>
[landing-page] LEGAL_ENTITY for FR
</commit_message>
<xml_diff>
--- a/docs/NEXOPS ONE™ — Venture Days Pitch.pptx
+++ b/docs/NEXOPS ONE™ — Venture Days Pitch.pptx
@@ -4,6 +4,9 @@
   <p:sldMasterIdLst>
     <p:sldMasterId id="2147483648" r:id="rId1"/>
   </p:sldMasterIdLst>
+  <p:notesMasterIdLst>
+    <p:notesMasterId r:id="rId10"/>
+  </p:notesMasterIdLst>
   <p:sldIdLst>
     <p:sldId id="256" r:id="rId2"/>
     <p:sldId id="257" r:id="rId3"/>
@@ -14,9 +17,6 @@
     <p:sldId id="262" r:id="rId8"/>
     <p:sldId id="263" r:id="rId9"/>
   </p:sldIdLst>
-  <p:notesMasterIdLst>
-    <p:notesMasterId r:id="rId10"/>
-  </p:notesMasterIdLst>
   <p:sldSz cx="12192000" cy="6858000"/>
   <p:notesSz cx="6858000" cy="12192000"/>
   <p:defaultTextStyle>
@@ -111,6 +111,11 @@
       </a:defRPr>
     </a:lvl9pPr>
   </p:defaultTextStyle>
+  <p:extLst>
+    <p:ext uri="{EFAFB233-063F-42B5-8137-9DF3F51BA10A}">
+      <p15:sldGuideLst xmlns:p15="http://schemas.microsoft.com/office/powerpoint/2012/main"/>
+    </p:ext>
+  </p:extLst>
 </p:presentation>
 </file>
 
@@ -136,234 +141,10 @@
           <a:chExt cx="0" cy="0"/>
         </a:xfrm>
       </p:grpSpPr>
-      <p:sp>
-        <p:nvSpPr>
-          <p:cNvPr id="2" name="Header Placeholder 1"/>
-          <p:cNvSpPr>
-            <a:spLocks noGrp="1"/>
-          </p:cNvSpPr>
-          <p:nvPr>
-            <p:ph type="hdr" sz="quarter"/>
-          </p:nvPr>
-        </p:nvSpPr>
-        <p:spPr>
-          <a:xfrm>
-            <a:off x="0" y="0"/>
-            <a:ext cx="2971800" cy="458788"/>
-          </a:xfrm>
-          <a:prstGeom prst="rect">
-            <a:avLst/>
-          </a:prstGeom>
-        </p:spPr>
-        <p:txBody>
-          <a:bodyPr vert="horz" lIns="91440" tIns="45720" rIns="91440" bIns="45720" rtlCol="0"/>
-          <a:lstStyle>
-            <a:lvl1pPr algn="l">
-              <a:defRPr sz="1200"/>
-            </a:lvl1pPr>
-          </a:lstStyle>
-          <a:p>
-            <a:endParaRPr lang="en-US"/>
-          </a:p>
-        </p:txBody>
-      </p:sp>
-      <p:sp>
-        <p:nvSpPr>
-          <p:cNvPr id="3" name="Date Placeholder 2"/>
-          <p:cNvSpPr>
-            <a:spLocks noGrp="1"/>
-          </p:cNvSpPr>
-          <p:nvPr>
-            <p:ph type="dt" idx="1"/>
-          </p:nvPr>
-        </p:nvSpPr>
-        <p:spPr>
-          <a:xfrm>
-            <a:off x="3884613" y="0"/>
-            <a:ext cx="2971800" cy="458788"/>
-          </a:xfrm>
-          <a:prstGeom prst="rect">
-            <a:avLst/>
-          </a:prstGeom>
-        </p:spPr>
-        <p:txBody>
-          <a:bodyPr vert="horz" lIns="91440" tIns="45720" rIns="91440" bIns="45720" rtlCol="0"/>
-          <a:lstStyle>
-            <a:lvl1pPr algn="r">
-              <a:defRPr sz="1200"/>
-            </a:lvl1pPr>
-          </a:lstStyle>
-          <a:p>
-            <a:fld id="{5282F153-3F37-0F45-9E97-73ACFA13230C}" type="datetimeFigureOut">
-              <a:rPr lang="en-US"/>
-              <a:t>7/23/19</a:t>
-            </a:fld>
-            <a:endParaRPr lang="en-US"/>
-          </a:p>
-        </p:txBody>
-      </p:sp>
-      <p:sp>
-        <p:nvSpPr>
-          <p:cNvPr id="4" name="Slide Image Placeholder 3"/>
-          <p:cNvSpPr>
-            <a:spLocks noGrp="1" noRot="1" noChangeAspect="1"/>
-          </p:cNvSpPr>
-          <p:nvPr>
-            <p:ph type="sldImg" idx="2"/>
-          </p:nvPr>
-        </p:nvSpPr>
-        <p:spPr>
-          <a:xfrm>
-            <a:off x="685800" y="1143000"/>
-            <a:ext cx="5486400" cy="3086100"/>
-          </a:xfrm>
-          <a:prstGeom prst="rect">
-            <a:avLst/>
-          </a:prstGeom>
-          <a:noFill/>
-          <a:ln w="12700">
-            <a:solidFill>
-              <a:prstClr val="black"/>
-            </a:solidFill>
-          </a:ln>
-        </p:spPr>
-        <p:txBody>
-          <a:bodyPr vert="horz" lIns="91440" tIns="45720" rIns="91440" bIns="45720" rtlCol="0" anchor="ctr"/>
-          <a:lstStyle/>
-          <a:p>
-            <a:endParaRPr lang="en-US"/>
-          </a:p>
-        </p:txBody>
-      </p:sp>
-      <p:sp>
-        <p:nvSpPr>
-          <p:cNvPr id="5" name="Notes Placeholder 4"/>
-          <p:cNvSpPr>
-            <a:spLocks noGrp="1"/>
-          </p:cNvSpPr>
-          <p:nvPr>
-            <p:ph type="body" sz="quarter" idx="3"/>
-          </p:nvPr>
-        </p:nvSpPr>
-        <p:spPr>
-          <a:xfrm>
-            <a:off x="685800" y="4400550"/>
-            <a:ext cx="5486400" cy="3600450"/>
-          </a:xfrm>
-          <a:prstGeom prst="rect">
-            <a:avLst/>
-          </a:prstGeom>
-        </p:spPr>
-        <p:txBody>
-          <a:bodyPr vert="horz" lIns="91440" tIns="45720" rIns="91440" bIns="45720" rtlCol="0"/>
-          <a:lstStyle/>
-          <a:p>
-            <a:pPr lvl="0"/>
-            <a:r>
-              <a:rPr lang="en-US"/>
-              <a:t>Click to edit Master text styles</a:t>
-            </a:r>
-          </a:p>
-          <a:p>
-            <a:pPr lvl="1"/>
-            <a:r>
-              <a:rPr lang="en-US"/>
-              <a:t>Second level</a:t>
-            </a:r>
-          </a:p>
-          <a:p>
-            <a:pPr lvl="2"/>
-            <a:r>
-              <a:rPr lang="en-US"/>
-              <a:t>Third level</a:t>
-            </a:r>
-          </a:p>
-          <a:p>
-            <a:pPr lvl="3"/>
-            <a:r>
-              <a:rPr lang="en-US"/>
-              <a:t>Fourth level</a:t>
-            </a:r>
-          </a:p>
-          <a:p>
-            <a:pPr lvl="4"/>
-            <a:r>
-              <a:rPr lang="en-US"/>
-              <a:t>Fifth level</a:t>
-            </a:r>
-          </a:p>
-        </p:txBody>
-      </p:sp>
-      <p:sp>
-        <p:nvSpPr>
-          <p:cNvPr id="6" name="Footer Placeholder 5"/>
-          <p:cNvSpPr>
-            <a:spLocks noGrp="1"/>
-          </p:cNvSpPr>
-          <p:nvPr>
-            <p:ph type="ftr" sz="quarter" idx="4"/>
-          </p:nvPr>
-        </p:nvSpPr>
-        <p:spPr>
-          <a:xfrm>
-            <a:off x="0" y="8685213"/>
-            <a:ext cx="2971800" cy="458787"/>
-          </a:xfrm>
-          <a:prstGeom prst="rect">
-            <a:avLst/>
-          </a:prstGeom>
-        </p:spPr>
-        <p:txBody>
-          <a:bodyPr vert="horz" lIns="91440" tIns="45720" rIns="91440" bIns="45720" rtlCol="0" anchor="b"/>
-          <a:lstStyle>
-            <a:lvl1pPr algn="l">
-              <a:defRPr sz="1200"/>
-            </a:lvl1pPr>
-          </a:lstStyle>
-          <a:p>
-            <a:endParaRPr lang="en-US"/>
-          </a:p>
-        </p:txBody>
-      </p:sp>
-      <p:sp>
-        <p:nvSpPr>
-          <p:cNvPr id="7" name="Slide Number Placeholder 6"/>
-          <p:cNvSpPr>
-            <a:spLocks noGrp="1"/>
-          </p:cNvSpPr>
-          <p:nvPr>
-            <p:ph type="sldNum" sz="quarter" idx="5"/>
-          </p:nvPr>
-        </p:nvSpPr>
-        <p:spPr>
-          <a:xfrm>
-            <a:off x="3884613" y="8685213"/>
-            <a:ext cx="2971800" cy="458787"/>
-          </a:xfrm>
-          <a:prstGeom prst="rect">
-            <a:avLst/>
-          </a:prstGeom>
-        </p:spPr>
-        <p:txBody>
-          <a:bodyPr vert="horz" lIns="91440" tIns="45720" rIns="91440" bIns="45720" rtlCol="0" anchor="b"/>
-          <a:lstStyle>
-            <a:lvl1pPr algn="r">
-              <a:defRPr sz="1200"/>
-            </a:lvl1pPr>
-          </a:lstStyle>
-          <a:p>
-            <a:fld id="{CE5E9CC1-C706-0F49-92D6-E571CC5EEA8F}" type="slidenum">
-              <a:rPr lang="en-US"/>
-              <a:t>‹#›</a:t>
-            </a:fld>
-            <a:endParaRPr lang="en-US"/>
-          </a:p>
-        </p:txBody>
-      </p:sp>
     </p:spTree>
     <p:extLst>
       <p:ext uri="{BB962C8B-B14F-4D97-AF65-F5344CB8AC3E}">
-        <p14:creationId xmlns:p14="http://schemas.microsoft.com/office/powerpoint/2010/main" val="1024086991"/>
+        <p14:creationId xmlns:p14="http://schemas.microsoft.com/office/powerpoint/2010/main" val="1182802624"/>
       </p:ext>
     </p:extLst>
   </p:cSld>
@@ -511,7 +292,6 @@
               <a:rPr lang="en-US" dirty="0"/>
               <a:t>Open with the room: how many of the funds represented here filed a DORA register last March? Who is confident it passes next March's checks? Then the one-liner: we help Luxembourg fund managers and smaller regulated entities file a register that passes CSSF validation, and keep it accurate all year, with software that runs in their own environment.</a:t>
             </a:r>
-            <a:endParaRPr lang="en-US" dirty="0"/>
           </a:p>
         </p:txBody>
       </p:sp>
@@ -599,7 +379,6 @@
               <a:rPr lang="en-US" dirty="0"/>
               <a:t>Every CSSF-supervised entity must file a DORA register of all its ICT providers every year. The checks are getting stricter: the CSSF itself warned that registers accepted in 2025 may be rejected in 2026, because the same checks now apply to more fields. In one analysis of 947 registers, only 6.5% passed every check, and 86% of errors were simply missing mandatory data. Big entities throw consultants at this. A 15-person ManCo can't.</a:t>
             </a:r>
-            <a:endParaRPr lang="en-US" dirty="0"/>
           </a:p>
         </p:txBody>
       </p:sp>
@@ -687,7 +466,6 @@
               <a:rPr lang="en-US" dirty="0"/>
               <a:t>Switch to the laptop. Demo Bank, a fictitious entity: import the sample register, show the validation report and coverage, open one control that cannot be assessed because data is missing, attach evidence, approve it as the approver, generate the report. Keep it to 90 seconds. Say: it runs in your own environment and it's open source, so it doesn't become another vendor you have to register and assess. Do not call the export CSSF-ready: it is aligned with the EBA format and the official rules load before the 2027 filing.</a:t>
             </a:r>
-            <a:endParaRPr lang="en-US" dirty="0"/>
           </a:p>
         </p:txBody>
       </p:sp>
@@ -775,7 +553,6 @@
               <a:rPr lang="en-US" dirty="0"/>
               <a:t>Every SaaS compliance tool becomes one more ICT third party in the very register it helps you build: another contract to assess, another concentration to report. Ours runs inside your perimeter, the core is open source with a documented exit plan, and it ships its own entry for your register. And because I come from finance IT missions and multi-cloud infrastructure, I understand both the register and the cloud architecture behind it, which most compliance-only consultancies don't.</a:t>
             </a:r>
-            <a:endParaRPr lang="en-US" dirty="0"/>
           </a:p>
         </p:txBody>
       </p:sp>
@@ -863,7 +640,6 @@
               <a:rPr lang="en-US" dirty="0"/>
               <a:t>Open core: the free engine builds trust and adoption. What clients pay for is what the regulator requires: the register export, the maintained rule catalog that updates every year as validation tightens, and multi-entity administration. The channel licence lets a third-party ManCo or a boutique consultancy run all its client entities from one install, which is how we scale beyond one entity at a time. Prices are hypotheses we test in the first conversations.</a:t>
             </a:r>
-            <a:endParaRPr lang="en-US" dirty="0"/>
           </a:p>
         </p:txBody>
       </p:sp>
@@ -951,7 +727,6 @@
               <a:rPr lang="en-US" dirty="0"/>
               <a:t>Fill the two numbers on the morning of the pitch; if a design partner agreed to be named, name them. The product is not a mock-up: the open-core engine and the commercial edition both run today. Be precise on one point if asked: the register export follows the EBA xBRL-CSV structure; the official taxonomy and validation rules are loaded before the 2027 filing.</a:t>
             </a:r>
-            <a:endParaRPr lang="en-US" dirty="0"/>
           </a:p>
         </p:txBody>
       </p:sp>
@@ -1039,7 +814,6 @@
               <a:rPr lang="en-US" dirty="0"/>
               <a:t>Next March's filing is our launch window: five months from today is exactly one sales cycle. After that, the same buyer asks the next question: how concentrated are we on one cloud provider, and what would it really cost to leave? That's NEXOPS ONE, our cloud economics and sovereignty platform, which already connects read-only to Azure and AWS. Same buyer, second product.</a:t>
             </a:r>
-            <a:endParaRPr lang="en-US" dirty="0"/>
           </a:p>
         </p:txBody>
       </p:sp>
@@ -1127,7 +901,6 @@
               <a:rPr lang="en-US" dirty="0"/>
               <a:t>We're looking for three Luxembourg fund managers to file with us in March, and for introductions to ALFI and LPEA compliance officers. Fit 4 Start funds the work that turns the product into the filing tool: the official EBA rules, legal review, a Luxembourg-hosted option for clients without an IT team, and a compliance partner on the team. Close by offering the free Register Health Check to anyone in the room.</a:t>
             </a:r>
-            <a:endParaRPr lang="en-US" dirty="0"/>
           </a:p>
         </p:txBody>
       </p:sp>
@@ -1205,6 +978,7 @@
         <a:solidFill>
           <a:srgbClr val="F6F4EE"/>
         </a:solidFill>
+        <a:effectLst/>
       </p:bgPr>
     </p:bg>
     <p:spTree>
@@ -1224,7 +998,9 @@
       <p:sp>
         <p:nvSpPr>
           <p:cNvPr id="2" name="Title Placeholder 1"/>
-          <p:cNvSpPr/>
+          <p:cNvSpPr>
+            <a:spLocks noGrp="1"/>
+          </p:cNvSpPr>
           <p:nvPr>
             <p:ph type="title"/>
           </p:nvPr>
@@ -1243,7 +1019,7 @@
         <p:txBody>
           <a:bodyPr wrap="square" lIns="0" tIns="0" rIns="0" bIns="0" rtlCol="0" anchor="t"/>
           <a:lstStyle>
-            <a:lvl1pPr algn="l" indent="0" marL="0">
+            <a:lvl1pPr marL="0" indent="0" algn="l">
               <a:lnSpc>
                 <a:spcPct val="115000"/>
               </a:lnSpc>
@@ -1259,7 +1035,7 @@
             </a:lvl1pPr>
           </a:lstStyle>
           <a:p>
-            <a:pPr algn="l" indent="0" marL="0">
+            <a:pPr marL="0" indent="0" algn="l">
               <a:lnSpc>
                 <a:spcPct val="115000"/>
               </a:lnSpc>
@@ -1272,9 +1048,11 @@
       <p:sp>
         <p:nvSpPr>
           <p:cNvPr id="3" name="Text Placeholder 2"/>
-          <p:cNvSpPr/>
+          <p:cNvSpPr>
+            <a:spLocks noGrp="1"/>
+          </p:cNvSpPr>
           <p:nvPr>
-            <p:ph idx="101" type="body"/>
+            <p:ph type="body" idx="101"/>
           </p:nvPr>
         </p:nvSpPr>
         <p:spPr>
@@ -1291,7 +1069,7 @@
         <p:txBody>
           <a:bodyPr wrap="square" lIns="0" tIns="0" rIns="0" bIns="0" rtlCol="0" anchor="t"/>
           <a:lstStyle>
-            <a:lvl1pPr algn="l" indent="0" marL="0">
+            <a:lvl1pPr marL="0" indent="0" algn="l">
               <a:lnSpc>
                 <a:spcPct val="140000"/>
               </a:lnSpc>
@@ -1307,7 +1085,7 @@
             </a:lvl1pPr>
           </a:lstStyle>
           <a:p>
-            <a:pPr algn="l" indent="0" marL="0">
+            <a:pPr marL="0" indent="0" algn="l">
               <a:lnSpc>
                 <a:spcPct val="140000"/>
               </a:lnSpc>
@@ -1333,6 +1111,7 @@
         <a:solidFill>
           <a:srgbClr val="F6F4EE"/>
         </a:solidFill>
+        <a:effectLst/>
       </p:bgPr>
     </p:bg>
     <p:spTree>
@@ -1352,7 +1131,9 @@
       <p:sp>
         <p:nvSpPr>
           <p:cNvPr id="2" name="Title Placeholder 1"/>
-          <p:cNvSpPr/>
+          <p:cNvSpPr>
+            <a:spLocks noGrp="1"/>
+          </p:cNvSpPr>
           <p:nvPr>
             <p:ph type="title"/>
           </p:nvPr>
@@ -1371,7 +1152,7 @@
         <p:txBody>
           <a:bodyPr wrap="square" lIns="0" tIns="0" rIns="0" bIns="0" rtlCol="0" anchor="t"/>
           <a:lstStyle>
-            <a:lvl1pPr algn="l" indent="0" marL="0">
+            <a:lvl1pPr marL="0" indent="0" algn="l">
               <a:lnSpc>
                 <a:spcPct val="115000"/>
               </a:lnSpc>
@@ -1387,7 +1168,7 @@
             </a:lvl1pPr>
           </a:lstStyle>
           <a:p>
-            <a:pPr algn="l" indent="0" marL="0">
+            <a:pPr marL="0" indent="0" algn="l">
               <a:lnSpc>
                 <a:spcPct val="115000"/>
               </a:lnSpc>
@@ -1400,9 +1181,11 @@
       <p:sp>
         <p:nvSpPr>
           <p:cNvPr id="3" name="Text Placeholder 2"/>
-          <p:cNvSpPr/>
+          <p:cNvSpPr>
+            <a:spLocks noGrp="1"/>
+          </p:cNvSpPr>
           <p:nvPr>
-            <p:ph idx="101" type="body"/>
+            <p:ph type="body" idx="101"/>
           </p:nvPr>
         </p:nvSpPr>
         <p:spPr>
@@ -1419,7 +1202,7 @@
         <p:txBody>
           <a:bodyPr wrap="square" lIns="0" tIns="0" rIns="0" bIns="0" rtlCol="0" anchor="t"/>
           <a:lstStyle>
-            <a:lvl1pPr algn="l" indent="0" marL="0">
+            <a:lvl1pPr marL="0" indent="0" algn="l">
               <a:lnSpc>
                 <a:spcPct val="140000"/>
               </a:lnSpc>
@@ -1435,7 +1218,7 @@
             </a:lvl1pPr>
           </a:lstStyle>
           <a:p>
-            <a:pPr algn="l" indent="0" marL="0">
+            <a:pPr marL="0" indent="0" algn="l">
               <a:lnSpc>
                 <a:spcPct val="140000"/>
               </a:lnSpc>
@@ -1714,6 +1497,7 @@
         <a:solidFill>
           <a:srgbClr val="14213D"/>
         </a:solidFill>
+        <a:effectLst/>
       </p:bgPr>
     </p:bg>
     <p:spTree>
@@ -1753,14 +1537,14 @@
           </a:bodyPr>
           <a:lstStyle/>
           <a:p>
-            <a:pPr algn="l" indent="0" marL="0">
+            <a:pPr marL="0" indent="0" algn="l">
               <a:lnSpc>
                 <a:spcPts val="1680"/>
               </a:lnSpc>
               <a:buNone/>
             </a:pPr>
             <a:r>
-              <a:rPr lang="en-US" sz="1200" b="1" spc="100" kern="0" dirty="0">
+              <a:rPr lang="en-US" sz="1200" b="1" kern="0" spc="100" dirty="0">
                 <a:solidFill>
                   <a:srgbClr val="F2A65A"/>
                 </a:solidFill>
@@ -1768,7 +1552,7 @@
                 <a:ea typeface="IBM Plex Sans" pitchFamily="34" charset="-122"/>
                 <a:cs typeface="IBM Plex Sans" pitchFamily="34" charset="-120"/>
               </a:rPr>
-              <a:t>NEXOPS ONE · LUXEMBOURG VENTURE DAYS 2026 · FIT 4 START #17</a:t>
+              <a:t>NEXOPS ONE · LUXEMBOURG VENTURE DAYS 2026 · FIT 4 START #18</a:t>
             </a:r>
             <a:endParaRPr lang="en-US" sz="1200" dirty="0"/>
           </a:p>
@@ -1777,7 +1561,9 @@
       <p:sp>
         <p:nvSpPr>
           <p:cNvPr id="3" name="Text 1"/>
-          <p:cNvSpPr/>
+          <p:cNvSpPr>
+            <a:spLocks noGrp="1"/>
+          </p:cNvSpPr>
           <p:nvPr>
             <p:ph type="title"/>
           </p:nvPr>
@@ -1799,7 +1585,7 @@
           </a:bodyPr>
           <a:lstStyle/>
           <a:p>
-            <a:pPr algn="l" indent="0" marL="0">
+            <a:pPr marL="0" indent="0" algn="l">
               <a:lnSpc>
                 <a:spcPts val="5880"/>
               </a:lnSpc>
@@ -1819,7 +1605,7 @@
             <a:endParaRPr lang="en-US" sz="5600" dirty="0"/>
           </a:p>
           <a:p>
-            <a:pPr algn="l" indent="0" marL="0">
+            <a:pPr marL="0" indent="0" algn="l">
               <a:lnSpc>
                 <a:spcPts val="5880"/>
               </a:lnSpc>
@@ -1863,7 +1649,7 @@
           </a:bodyPr>
           <a:lstStyle/>
           <a:p>
-            <a:pPr algn="l" indent="0" marL="0">
+            <a:pPr marL="0" indent="0" algn="l">
               <a:lnSpc>
                 <a:spcPts val="2240"/>
               </a:lnSpc>
@@ -1907,7 +1693,7 @@
           </a:bodyPr>
           <a:lstStyle/>
           <a:p>
-            <a:pPr algn="l" indent="0" marL="0">
+            <a:pPr marL="0" indent="0" algn="l">
               <a:lnSpc>
                 <a:spcPts val="1680"/>
               </a:lnSpc>
@@ -1922,7 +1708,18 @@
                 <a:ea typeface="IBM Plex Sans" pitchFamily="34" charset="-122"/>
                 <a:cs typeface="IBM Plex Sans" pitchFamily="34" charset="-120"/>
               </a:rPr>
-              <a:t>[Founder name] · [email]</a:t>
+              <a:t>Nephthali DJABON TCHOUNDA · </a:t>
+            </a:r>
+            <a:r>
+              <a:rPr lang="en-US" sz="1200" dirty="0" err="1">
+                <a:solidFill>
+                  <a:srgbClr val="C9CFDB"/>
+                </a:solidFill>
+                <a:latin typeface="IBM Plex Sans" pitchFamily="34" charset="0"/>
+                <a:ea typeface="IBM Plex Sans" pitchFamily="34" charset="-122"/>
+                <a:cs typeface="IBM Plex Sans" pitchFamily="34" charset="-120"/>
+              </a:rPr>
+              <a:t>services@securaops.site</a:t>
             </a:r>
             <a:endParaRPr lang="en-US" sz="1200" dirty="0"/>
           </a:p>
@@ -1944,6 +1741,7 @@
         <a:solidFill>
           <a:srgbClr val="F6F4EE"/>
         </a:solidFill>
+        <a:effectLst/>
       </p:bgPr>
     </p:bg>
     <p:spTree>
@@ -1983,14 +1781,14 @@
           </a:bodyPr>
           <a:lstStyle/>
           <a:p>
-            <a:pPr algn="l" indent="0" marL="0">
+            <a:pPr marL="0" indent="0" algn="l">
               <a:lnSpc>
                 <a:spcPts val="1680"/>
               </a:lnSpc>
               <a:buNone/>
             </a:pPr>
             <a:r>
-              <a:rPr lang="en-US" sz="1200" b="1" spc="100" kern="0" dirty="0">
+              <a:rPr lang="en-US" sz="1200" b="1" kern="0" spc="100" dirty="0">
                 <a:solidFill>
                   <a:srgbClr val="B5481A"/>
                 </a:solidFill>
@@ -2007,7 +1805,9 @@
       <p:sp>
         <p:nvSpPr>
           <p:cNvPr id="3" name="Text 1"/>
-          <p:cNvSpPr/>
+          <p:cNvSpPr>
+            <a:spLocks noGrp="1"/>
+          </p:cNvSpPr>
           <p:nvPr>
             <p:ph type="title"/>
           </p:nvPr>
@@ -2029,7 +1829,7 @@
           </a:bodyPr>
           <a:lstStyle/>
           <a:p>
-            <a:pPr algn="l" indent="0" marL="0">
+            <a:pPr marL="0" indent="0" algn="l">
               <a:lnSpc>
                 <a:spcPts val="3680"/>
               </a:lnSpc>
@@ -2100,7 +1900,7 @@
           </a:bodyPr>
           <a:lstStyle/>
           <a:p>
-            <a:pPr algn="l" indent="0" marL="0">
+            <a:pPr marL="0" indent="0" algn="l">
               <a:lnSpc>
                 <a:spcPts val="6000"/>
               </a:lnSpc>
@@ -2115,7 +1915,7 @@
                 <a:ea typeface="Source Serif 4" pitchFamily="18" charset="-122"/>
                 <a:cs typeface="Source Serif 4" pitchFamily="18" charset="-120"/>
               </a:rPr>
-              <a:t>6.5%</a:t>
+              <a:t>40%</a:t>
             </a:r>
             <a:endParaRPr lang="en-US" sz="6000" dirty="0"/>
           </a:p>
@@ -2140,26 +1940,18 @@
         </p:spPr>
         <p:txBody>
           <a:bodyPr wrap="square" lIns="0" tIns="0" rIns="0" bIns="0" rtlCol="0" anchor="t">
-            <a:normAutofit/>
+            <a:normAutofit fontScale="70000" lnSpcReduction="20000"/>
           </a:bodyPr>
           <a:lstStyle/>
           <a:p>
-            <a:pPr algn="l" indent="0" marL="0">
+            <a:pPr>
               <a:lnSpc>
                 <a:spcPts val="2025"/>
               </a:lnSpc>
-              <a:buNone/>
-            </a:pPr>
-            <a:r>
-              <a:rPr lang="en-US" sz="1500" dirty="0">
-                <a:solidFill>
-                  <a:srgbClr val="4A5568"/>
-                </a:solidFill>
-                <a:latin typeface="IBM Plex Sans" pitchFamily="34" charset="0"/>
-                <a:ea typeface="IBM Plex Sans" pitchFamily="34" charset="-122"/>
-                <a:cs typeface="IBM Plex Sans" pitchFamily="34" charset="-120"/>
-              </a:rPr>
-              <a:t>of registers analysed passed all 116 validation checks</a:t>
+            </a:pPr>
+            <a:r>
+              <a:rPr lang="en-US" dirty="0"/>
+              <a:t>of entities required to file a register had done so as of 16 March</a:t>
             </a:r>
             <a:endParaRPr lang="en-US" sz="1500" dirty="0"/>
           </a:p>
@@ -2215,22 +2007,20 @@
           </a:bodyPr>
           <a:lstStyle/>
           <a:p>
-            <a:pPr algn="l" indent="0" marL="0">
+            <a:pPr>
               <a:lnSpc>
                 <a:spcPts val="6000"/>
               </a:lnSpc>
-              <a:buNone/>
-            </a:pPr>
-            <a:r>
-              <a:rPr lang="en-US" sz="6000" b="1" dirty="0">
+            </a:pPr>
+            <a:r>
+              <a:rPr lang="fr-LU" sz="6000" b="1" dirty="0">
                 <a:solidFill>
                   <a:srgbClr val="B5481A"/>
                 </a:solidFill>
                 <a:latin typeface="Source Serif 4" pitchFamily="18" charset="0"/>
                 <a:ea typeface="Source Serif 4" pitchFamily="18" charset="-122"/>
-                <a:cs typeface="Source Serif 4" pitchFamily="18" charset="-120"/>
-              </a:rPr>
-              <a:t>86%</a:t>
+              </a:rPr>
+              <a:t>31.03</a:t>
             </a:r>
             <a:endParaRPr lang="en-US" sz="6000" dirty="0"/>
           </a:p>
@@ -2255,26 +2045,26 @@
         </p:spPr>
         <p:txBody>
           <a:bodyPr wrap="square" lIns="0" tIns="0" rIns="0" bIns="0" rtlCol="0" anchor="t">
-            <a:normAutofit/>
+            <a:normAutofit fontScale="77500" lnSpcReduction="20000"/>
           </a:bodyPr>
           <a:lstStyle/>
           <a:p>
-            <a:pPr algn="l" indent="0" marL="0">
+            <a:pPr>
               <a:lnSpc>
                 <a:spcPts val="2025"/>
               </a:lnSpc>
-              <a:buNone/>
-            </a:pPr>
-            <a:r>
-              <a:rPr lang="en-US" sz="1500" dirty="0">
-                <a:solidFill>
-                  <a:srgbClr val="4A5568"/>
-                </a:solidFill>
-                <a:latin typeface="IBM Plex Sans" pitchFamily="34" charset="0"/>
-                <a:ea typeface="IBM Plex Sans" pitchFamily="34" charset="-122"/>
-                <a:cs typeface="IBM Plex Sans" pitchFamily="34" charset="-120"/>
-              </a:rPr>
-              <a:t>of the errors were simply missing mandatory data</a:t>
+            </a:pPr>
+            <a:r>
+              <a:rPr lang="en-US" dirty="0"/>
+              <a:t>filing deadline set by the CSSF in 2026 (</a:t>
+            </a:r>
+            <a:r>
+              <a:rPr lang="en-US" dirty="0" err="1"/>
+              <a:t>eDesk</a:t>
+            </a:r>
+            <a:r>
+              <a:rPr lang="en-US" dirty="0"/>
+              <a:t> opened 11 February)</a:t>
             </a:r>
             <a:endParaRPr lang="en-US" sz="1500" dirty="0"/>
           </a:p>
@@ -2326,7 +2116,7 @@
           </a:bodyPr>
           <a:lstStyle/>
           <a:p>
-            <a:pPr algn="l" indent="0" marL="0">
+            <a:pPr marL="0" indent="0" algn="l">
               <a:lnSpc>
                 <a:spcPts val="2160"/>
               </a:lnSpc>
@@ -2370,7 +2160,7 @@
           </a:bodyPr>
           <a:lstStyle/>
           <a:p>
-            <a:pPr algn="l" marL="182880" indent="-182880">
+            <a:pPr marL="182880" indent="-182880" algn="l">
               <a:lnSpc>
                 <a:spcPts val="2175"/>
               </a:lnSpc>
@@ -2391,7 +2181,7 @@
             <a:endParaRPr lang="en-US" sz="1500" dirty="0"/>
           </a:p>
           <a:p>
-            <a:pPr algn="l" marL="182880" indent="-182880">
+            <a:pPr marL="182880" indent="-182880" algn="l">
               <a:lnSpc>
                 <a:spcPts val="2175"/>
               </a:lnSpc>
@@ -2412,7 +2202,7 @@
             <a:endParaRPr lang="en-US" sz="1500" dirty="0"/>
           </a:p>
           <a:p>
-            <a:pPr algn="l" marL="182880" indent="-182880">
+            <a:pPr marL="182880" indent="-182880" algn="l">
               <a:lnSpc>
                 <a:spcPts val="2175"/>
               </a:lnSpc>
@@ -2457,7 +2247,7 @@
           </a:bodyPr>
           <a:lstStyle/>
           <a:p>
-            <a:pPr algn="l" indent="0" marL="0">
+            <a:pPr marL="0" indent="0" algn="l">
               <a:lnSpc>
                 <a:spcPts val="1680"/>
               </a:lnSpc>
@@ -2494,6 +2284,7 @@
         <a:solidFill>
           <a:srgbClr val="F6F4EE"/>
         </a:solidFill>
+        <a:effectLst/>
       </p:bgPr>
     </p:bg>
     <p:spTree>
@@ -2533,14 +2324,14 @@
           </a:bodyPr>
           <a:lstStyle/>
           <a:p>
-            <a:pPr algn="l" indent="0" marL="0">
+            <a:pPr marL="0" indent="0" algn="l">
               <a:lnSpc>
                 <a:spcPts val="1680"/>
               </a:lnSpc>
               <a:buNone/>
             </a:pPr>
             <a:r>
-              <a:rPr lang="en-US" sz="1200" b="1" spc="100" kern="0" dirty="0">
+              <a:rPr lang="en-US" sz="1200" b="1" kern="0" spc="100" dirty="0">
                 <a:solidFill>
                   <a:srgbClr val="B5481A"/>
                 </a:solidFill>
@@ -2557,7 +2348,9 @@
       <p:sp>
         <p:nvSpPr>
           <p:cNvPr id="3" name="Text 1"/>
-          <p:cNvSpPr/>
+          <p:cNvSpPr>
+            <a:spLocks noGrp="1"/>
+          </p:cNvSpPr>
           <p:nvPr>
             <p:ph type="title"/>
           </p:nvPr>
@@ -2579,7 +2372,7 @@
           </a:bodyPr>
           <a:lstStyle/>
           <a:p>
-            <a:pPr algn="l" indent="0" marL="0">
+            <a:pPr marL="0" indent="0" algn="l">
               <a:lnSpc>
                 <a:spcPts val="3680"/>
               </a:lnSpc>
@@ -2650,7 +2443,7 @@
           </a:bodyPr>
           <a:lstStyle/>
           <a:p>
-            <a:pPr algn="l" indent="0" marL="0">
+            <a:pPr marL="0" indent="0" algn="l">
               <a:lnSpc>
                 <a:spcPts val="1680"/>
               </a:lnSpc>
@@ -2694,7 +2487,7 @@
           </a:bodyPr>
           <a:lstStyle/>
           <a:p>
-            <a:pPr algn="l" indent="0" marL="0">
+            <a:pPr marL="0" indent="0" algn="l">
               <a:lnSpc>
                 <a:spcPts val="2640"/>
               </a:lnSpc>
@@ -2738,7 +2531,7 @@
           </a:bodyPr>
           <a:lstStyle/>
           <a:p>
-            <a:pPr algn="l" indent="0" marL="0">
+            <a:pPr marL="0" indent="0" algn="l">
               <a:lnSpc>
                 <a:spcPts val="2100"/>
               </a:lnSpc>
@@ -2761,15 +2554,15 @@
       </p:sp>
       <p:pic>
         <p:nvPicPr>
-          <p:cNvPr id="8" name="Image 0" descr="arrow-right">    </p:cNvPr>
+          <p:cNvPr id="8" name="Image 0" descr="arrow-right"/>
           <p:cNvPicPr>
             <a:picLocks noChangeAspect="1"/>
           </p:cNvPicPr>
           <p:nvPr/>
         </p:nvPicPr>
         <p:blipFill>
-          <a:blip r:embed="rId1"/>
-          <a:srcRect l="0" r="0" t="0" b="0"/>
+          <a:blip r:embed="rId3"/>
+          <a:srcRect/>
           <a:stretch/>
         </p:blipFill>
         <p:spPr>
@@ -2832,7 +2625,7 @@
           </a:bodyPr>
           <a:lstStyle/>
           <a:p>
-            <a:pPr algn="l" indent="0" marL="0">
+            <a:pPr marL="0" indent="0" algn="l">
               <a:lnSpc>
                 <a:spcPts val="1680"/>
               </a:lnSpc>
@@ -2876,7 +2669,7 @@
           </a:bodyPr>
           <a:lstStyle/>
           <a:p>
-            <a:pPr algn="l" indent="0" marL="0">
+            <a:pPr marL="0" indent="0" algn="l">
               <a:lnSpc>
                 <a:spcPts val="2640"/>
               </a:lnSpc>
@@ -2920,7 +2713,7 @@
           </a:bodyPr>
           <a:lstStyle/>
           <a:p>
-            <a:pPr algn="l" indent="0" marL="0">
+            <a:pPr marL="0" indent="0" algn="l">
               <a:lnSpc>
                 <a:spcPts val="2100"/>
               </a:lnSpc>
@@ -2943,15 +2736,15 @@
       </p:sp>
       <p:pic>
         <p:nvPicPr>
-          <p:cNvPr id="13" name="Image 1" descr="arrow-right">    </p:cNvPr>
+          <p:cNvPr id="13" name="Image 1" descr="arrow-right"/>
           <p:cNvPicPr>
             <a:picLocks noChangeAspect="1"/>
           </p:cNvPicPr>
           <p:nvPr/>
         </p:nvPicPr>
         <p:blipFill>
-          <a:blip r:embed="rId2"/>
-          <a:srcRect l="0" r="0" t="0" b="0"/>
+          <a:blip r:embed="rId3"/>
+          <a:srcRect/>
           <a:stretch/>
         </p:blipFill>
         <p:spPr>
@@ -3014,7 +2807,7 @@
           </a:bodyPr>
           <a:lstStyle/>
           <a:p>
-            <a:pPr algn="l" indent="0" marL="0">
+            <a:pPr marL="0" indent="0" algn="l">
               <a:lnSpc>
                 <a:spcPts val="1680"/>
               </a:lnSpc>
@@ -3058,7 +2851,7 @@
           </a:bodyPr>
           <a:lstStyle/>
           <a:p>
-            <a:pPr algn="l" indent="0" marL="0">
+            <a:pPr marL="0" indent="0" algn="l">
               <a:lnSpc>
                 <a:spcPts val="2640"/>
               </a:lnSpc>
@@ -3102,7 +2895,7 @@
           </a:bodyPr>
           <a:lstStyle/>
           <a:p>
-            <a:pPr algn="l" indent="0" marL="0">
+            <a:pPr marL="0" indent="0" algn="l">
               <a:lnSpc>
                 <a:spcPts val="2100"/>
               </a:lnSpc>
@@ -3150,7 +2943,7 @@
           </a:bodyPr>
           <a:lstStyle/>
           <a:p>
-            <a:pPr algn="ctr" indent="0" marL="0">
+            <a:pPr marL="0" indent="0" algn="ctr">
               <a:lnSpc>
                 <a:spcPts val="1680"/>
               </a:lnSpc>
@@ -3187,6 +2980,7 @@
         <a:solidFill>
           <a:srgbClr val="E0662E"/>
         </a:solidFill>
+        <a:effectLst/>
       </p:bgPr>
     </p:bg>
     <p:spTree>
@@ -3226,14 +3020,14 @@
           </a:bodyPr>
           <a:lstStyle/>
           <a:p>
-            <a:pPr algn="l" indent="0" marL="0">
+            <a:pPr marL="0" indent="0" algn="l">
               <a:lnSpc>
                 <a:spcPts val="1680"/>
               </a:lnSpc>
               <a:buNone/>
             </a:pPr>
             <a:r>
-              <a:rPr lang="en-US" sz="1200" b="1" spc="100" kern="0" dirty="0">
+              <a:rPr lang="en-US" sz="1200" b="1" kern="0" spc="100" dirty="0">
                 <a:solidFill>
                   <a:srgbClr val="14213D"/>
                 </a:solidFill>
@@ -3250,7 +3044,9 @@
       <p:sp>
         <p:nvSpPr>
           <p:cNvPr id="3" name="Text 1"/>
-          <p:cNvSpPr/>
+          <p:cNvSpPr>
+            <a:spLocks noGrp="1"/>
+          </p:cNvSpPr>
           <p:nvPr>
             <p:ph type="title"/>
           </p:nvPr>
@@ -3272,7 +3068,7 @@
           </a:bodyPr>
           <a:lstStyle/>
           <a:p>
-            <a:pPr algn="l" indent="0" marL="0">
+            <a:pPr marL="0" indent="0" algn="l">
               <a:lnSpc>
                 <a:spcPts val="5184"/>
               </a:lnSpc>
@@ -3339,7 +3135,7 @@
           </a:bodyPr>
           <a:lstStyle/>
           <a:p>
-            <a:pPr algn="l" indent="0" marL="0">
+            <a:pPr marL="0" indent="0" algn="l">
               <a:lnSpc>
                 <a:spcPts val="2160"/>
               </a:lnSpc>
@@ -3383,7 +3179,7 @@
           </a:bodyPr>
           <a:lstStyle/>
           <a:p>
-            <a:pPr algn="l" indent="0" marL="0">
+            <a:pPr marL="0" indent="0" algn="l">
               <a:lnSpc>
                 <a:spcPts val="1960"/>
               </a:lnSpc>
@@ -3450,7 +3246,7 @@
           </a:bodyPr>
           <a:lstStyle/>
           <a:p>
-            <a:pPr algn="l" indent="0" marL="0">
+            <a:pPr marL="0" indent="0" algn="l">
               <a:lnSpc>
                 <a:spcPts val="2160"/>
               </a:lnSpc>
@@ -3494,7 +3290,7 @@
           </a:bodyPr>
           <a:lstStyle/>
           <a:p>
-            <a:pPr algn="l" indent="0" marL="0">
+            <a:pPr marL="0" indent="0" algn="l">
               <a:lnSpc>
                 <a:spcPts val="1960"/>
               </a:lnSpc>
@@ -3561,7 +3357,7 @@
           </a:bodyPr>
           <a:lstStyle/>
           <a:p>
-            <a:pPr algn="l" indent="0" marL="0">
+            <a:pPr marL="0" indent="0" algn="l">
               <a:lnSpc>
                 <a:spcPts val="2160"/>
               </a:lnSpc>
@@ -3605,7 +3401,7 @@
           </a:bodyPr>
           <a:lstStyle/>
           <a:p>
-            <a:pPr algn="l" indent="0" marL="0">
+            <a:pPr marL="0" indent="0" algn="l">
               <a:lnSpc>
                 <a:spcPts val="1960"/>
               </a:lnSpc>
@@ -3642,6 +3438,7 @@
         <a:solidFill>
           <a:srgbClr val="F6F4EE"/>
         </a:solidFill>
+        <a:effectLst/>
       </p:bgPr>
     </p:bg>
     <p:spTree>
@@ -3681,14 +3478,14 @@
           </a:bodyPr>
           <a:lstStyle/>
           <a:p>
-            <a:pPr algn="l" indent="0" marL="0">
+            <a:pPr marL="0" indent="0" algn="l">
               <a:lnSpc>
                 <a:spcPts val="1680"/>
               </a:lnSpc>
               <a:buNone/>
             </a:pPr>
             <a:r>
-              <a:rPr lang="en-US" sz="1200" b="1" spc="100" kern="0" dirty="0">
+              <a:rPr lang="en-US" sz="1200" b="1" kern="0" spc="100" dirty="0">
                 <a:solidFill>
                   <a:srgbClr val="B5481A"/>
                 </a:solidFill>
@@ -3705,7 +3502,9 @@
       <p:sp>
         <p:nvSpPr>
           <p:cNvPr id="3" name="Text 1"/>
-          <p:cNvSpPr/>
+          <p:cNvSpPr>
+            <a:spLocks noGrp="1"/>
+          </p:cNvSpPr>
           <p:nvPr>
             <p:ph type="title"/>
           </p:nvPr>
@@ -3727,7 +3526,7 @@
           </a:bodyPr>
           <a:lstStyle/>
           <a:p>
-            <a:pPr algn="l" indent="0" marL="0">
+            <a:pPr marL="0" indent="0" algn="l">
               <a:lnSpc>
                 <a:spcPts val="3680"/>
               </a:lnSpc>
@@ -3771,10 +3570,34 @@
             <a:tbl>
               <a:tblPr/>
               <a:tblGrid>
-                <a:gridCol w="2321814"/>
-                <a:gridCol w="3588258"/>
-                <a:gridCol w="2532888"/>
-                <a:gridCol w="2110740"/>
+                <a:gridCol w="2321814">
+                  <a:extLst>
+                    <a:ext uri="{9D8B030D-6E8A-4147-A177-3AD203B41FA5}">
+                      <a16:colId xmlns:a16="http://schemas.microsoft.com/office/drawing/2014/main" val="20000"/>
+                    </a:ext>
+                  </a:extLst>
+                </a:gridCol>
+                <a:gridCol w="3588258">
+                  <a:extLst>
+                    <a:ext uri="{9D8B030D-6E8A-4147-A177-3AD203B41FA5}">
+                      <a16:colId xmlns:a16="http://schemas.microsoft.com/office/drawing/2014/main" val="20001"/>
+                    </a:ext>
+                  </a:extLst>
+                </a:gridCol>
+                <a:gridCol w="2532888">
+                  <a:extLst>
+                    <a:ext uri="{9D8B030D-6E8A-4147-A177-3AD203B41FA5}">
+                      <a16:colId xmlns:a16="http://schemas.microsoft.com/office/drawing/2014/main" val="20002"/>
+                    </a:ext>
+                  </a:extLst>
+                </a:gridCol>
+                <a:gridCol w="2110740">
+                  <a:extLst>
+                    <a:ext uri="{9D8B030D-6E8A-4147-A177-3AD203B41FA5}">
+                      <a16:colId xmlns:a16="http://schemas.microsoft.com/office/drawing/2014/main" val="20003"/>
+                    </a:ext>
+                  </a:extLst>
+                </a:gridCol>
               </a:tblGrid>
               <a:tr h="359304">
                 <a:tc>
@@ -3782,7 +3605,7 @@
                     <a:bodyPr/>
                     <a:lstStyle/>
                     <a:p>
-                      <a:pPr indent="0" marL="0">
+                      <a:pPr marL="0" indent="0">
                         <a:lnSpc>
                           <a:spcPts val="1820"/>
                         </a:lnSpc>
@@ -3806,7 +3629,7 @@
                       </a:endParaRPr>
                     </a:p>
                   </a:txBody>
-                  <a:tcPr marL="57785" marR="57785" marT="57785" marB="57785" anchor="t">
+                  <a:tcPr marL="57785" marR="57785" marT="57785" marB="57785">
                     <a:lnL w="12700" cap="flat" cmpd="sng" algn="ctr">
                       <a:solidFill>
                         <a:srgbClr val="C4C3BE"/>
@@ -3853,7 +3676,7 @@
                     <a:bodyPr/>
                     <a:lstStyle/>
                     <a:p>
-                      <a:pPr indent="0" marL="0">
+                      <a:pPr marL="0" indent="0">
                         <a:lnSpc>
                           <a:spcPts val="1820"/>
                         </a:lnSpc>
@@ -3877,7 +3700,7 @@
                       </a:endParaRPr>
                     </a:p>
                   </a:txBody>
-                  <a:tcPr marL="57785" marR="57785" marT="57785" marB="57785" anchor="t">
+                  <a:tcPr marL="57785" marR="57785" marT="57785" marB="57785">
                     <a:lnL w="12700" cap="flat" cmpd="sng" algn="ctr">
                       <a:solidFill>
                         <a:srgbClr val="B6B5B0"/>
@@ -3924,7 +3747,7 @@
                     <a:bodyPr/>
                     <a:lstStyle/>
                     <a:p>
-                      <a:pPr indent="0" marL="0">
+                      <a:pPr marL="0" indent="0">
                         <a:lnSpc>
                           <a:spcPts val="1820"/>
                         </a:lnSpc>
@@ -3948,7 +3771,7 @@
                       </a:endParaRPr>
                     </a:p>
                   </a:txBody>
-                  <a:tcPr marL="57785" marR="57785" marT="57785" marB="57785" anchor="t">
+                  <a:tcPr marL="57785" marR="57785" marT="57785" marB="57785">
                     <a:lnL w="12700" cap="flat" cmpd="sng" algn="ctr">
                       <a:solidFill>
                         <a:srgbClr val="B6B5B0"/>
@@ -3995,7 +3818,7 @@
                     <a:bodyPr/>
                     <a:lstStyle/>
                     <a:p>
-                      <a:pPr indent="0" marL="0">
+                      <a:pPr marL="0" indent="0">
                         <a:lnSpc>
                           <a:spcPts val="1820"/>
                         </a:lnSpc>
@@ -4019,7 +3842,7 @@
                       </a:endParaRPr>
                     </a:p>
                   </a:txBody>
-                  <a:tcPr marL="57785" marR="57785" marT="57785" marB="57785" anchor="t">
+                  <a:tcPr marL="57785" marR="57785" marT="57785" marB="57785">
                     <a:lnL w="12700" cap="flat" cmpd="sng" algn="ctr">
                       <a:solidFill>
                         <a:srgbClr val="B6B5B0"/>
@@ -4061,6 +3884,11 @@
                     </a:solidFill>
                   </a:tcPr>
                 </a:tc>
+                <a:extLst>
+                  <a:ext uri="{0D108BD9-81ED-4DB2-BD59-A6C34878D82A}">
+                    <a16:rowId xmlns:a16="http://schemas.microsoft.com/office/drawing/2014/main" val="10000"/>
+                  </a:ext>
+                </a:extLst>
               </a:tr>
               <a:tr h="359304">
                 <a:tc>
@@ -4068,7 +3896,7 @@
                     <a:bodyPr/>
                     <a:lstStyle/>
                     <a:p>
-                      <a:pPr indent="0" marL="0">
+                      <a:pPr marL="0" indent="0">
                         <a:lnSpc>
                           <a:spcPts val="1820"/>
                         </a:lnSpc>
@@ -4092,7 +3920,7 @@
                       </a:endParaRPr>
                     </a:p>
                   </a:txBody>
-                  <a:tcPr marL="57785" marR="57785" marT="57785" marB="57785" anchor="t">
+                  <a:tcPr marL="57785" marR="57785" marT="57785" marB="57785">
                     <a:lnL w="12700" cap="flat" cmpd="sng" algn="ctr">
                       <a:solidFill>
                         <a:srgbClr val="C4C3BE"/>
@@ -4136,7 +3964,7 @@
                     <a:bodyPr/>
                     <a:lstStyle/>
                     <a:p>
-                      <a:pPr indent="0" marL="0">
+                      <a:pPr marL="0" indent="0">
                         <a:lnSpc>
                           <a:spcPts val="1820"/>
                         </a:lnSpc>
@@ -4160,7 +3988,7 @@
                       </a:endParaRPr>
                     </a:p>
                   </a:txBody>
-                  <a:tcPr marL="57785" marR="57785" marT="57785" marB="57785" anchor="t">
+                  <a:tcPr marL="57785" marR="57785" marT="57785" marB="57785">
                     <a:lnL w="12700" cap="flat" cmpd="sng" algn="ctr">
                       <a:solidFill>
                         <a:srgbClr val="C4C3BE"/>
@@ -4204,7 +4032,7 @@
                     <a:bodyPr/>
                     <a:lstStyle/>
                     <a:p>
-                      <a:pPr indent="0" marL="0">
+                      <a:pPr marL="0" indent="0">
                         <a:lnSpc>
                           <a:spcPts val="1820"/>
                         </a:lnSpc>
@@ -4228,7 +4056,7 @@
                       </a:endParaRPr>
                     </a:p>
                   </a:txBody>
-                  <a:tcPr marL="57785" marR="57785" marT="57785" marB="57785" anchor="t">
+                  <a:tcPr marL="57785" marR="57785" marT="57785" marB="57785">
                     <a:lnL w="12700" cap="flat" cmpd="sng" algn="ctr">
                       <a:solidFill>
                         <a:srgbClr val="C4C3BE"/>
@@ -4272,7 +4100,7 @@
                     <a:bodyPr/>
                     <a:lstStyle/>
                     <a:p>
-                      <a:pPr indent="0" marL="0">
+                      <a:pPr marL="0" indent="0">
                         <a:lnSpc>
                           <a:spcPts val="1820"/>
                         </a:lnSpc>
@@ -4296,7 +4124,7 @@
                       </a:endParaRPr>
                     </a:p>
                   </a:txBody>
-                  <a:tcPr marL="57785" marR="57785" marT="57785" marB="57785" anchor="t">
+                  <a:tcPr marL="57785" marR="57785" marT="57785" marB="57785">
                     <a:lnL w="12700" cap="flat" cmpd="sng" algn="ctr">
                       <a:solidFill>
                         <a:srgbClr val="C4C3BE"/>
@@ -4335,6 +4163,11 @@
                     </a:lnB>
                   </a:tcPr>
                 </a:tc>
+                <a:extLst>
+                  <a:ext uri="{0D108BD9-81ED-4DB2-BD59-A6C34878D82A}">
+                    <a16:rowId xmlns:a16="http://schemas.microsoft.com/office/drawing/2014/main" val="10001"/>
+                  </a:ext>
+                </a:extLst>
               </a:tr>
               <a:tr h="359304">
                 <a:tc>
@@ -4342,7 +4175,7 @@
                     <a:bodyPr/>
                     <a:lstStyle/>
                     <a:p>
-                      <a:pPr indent="0" marL="0">
+                      <a:pPr marL="0" indent="0">
                         <a:lnSpc>
                           <a:spcPts val="1820"/>
                         </a:lnSpc>
@@ -4366,7 +4199,7 @@
                       </a:endParaRPr>
                     </a:p>
                   </a:txBody>
-                  <a:tcPr marL="57785" marR="57785" marT="57785" marB="57785" anchor="t">
+                  <a:tcPr marL="57785" marR="57785" marT="57785" marB="57785">
                     <a:lnL w="12700" cap="flat" cmpd="sng" algn="ctr">
                       <a:solidFill>
                         <a:srgbClr val="C4C3BE"/>
@@ -4413,7 +4246,7 @@
                     <a:bodyPr/>
                     <a:lstStyle/>
                     <a:p>
-                      <a:pPr indent="0" marL="0">
+                      <a:pPr marL="0" indent="0">
                         <a:lnSpc>
                           <a:spcPts val="1820"/>
                         </a:lnSpc>
@@ -4437,7 +4270,7 @@
                       </a:endParaRPr>
                     </a:p>
                   </a:txBody>
-                  <a:tcPr marL="57785" marR="57785" marT="57785" marB="57785" anchor="t">
+                  <a:tcPr marL="57785" marR="57785" marT="57785" marB="57785">
                     <a:lnL w="12700" cap="flat" cmpd="sng" algn="ctr">
                       <a:solidFill>
                         <a:srgbClr val="CBCAC6"/>
@@ -4484,7 +4317,7 @@
                     <a:bodyPr/>
                     <a:lstStyle/>
                     <a:p>
-                      <a:pPr indent="0" marL="0">
+                      <a:pPr marL="0" indent="0">
                         <a:lnSpc>
                           <a:spcPts val="1820"/>
                         </a:lnSpc>
@@ -4508,7 +4341,7 @@
                       </a:endParaRPr>
                     </a:p>
                   </a:txBody>
-                  <a:tcPr marL="57785" marR="57785" marT="57785" marB="57785" anchor="t">
+                  <a:tcPr marL="57785" marR="57785" marT="57785" marB="57785">
                     <a:lnL w="12700" cap="flat" cmpd="sng" algn="ctr">
                       <a:solidFill>
                         <a:srgbClr val="CBCAC6"/>
@@ -4555,7 +4388,7 @@
                     <a:bodyPr/>
                     <a:lstStyle/>
                     <a:p>
-                      <a:pPr indent="0" marL="0">
+                      <a:pPr marL="0" indent="0">
                         <a:lnSpc>
                           <a:spcPts val="1820"/>
                         </a:lnSpc>
@@ -4579,7 +4412,7 @@
                       </a:endParaRPr>
                     </a:p>
                   </a:txBody>
-                  <a:tcPr marL="57785" marR="57785" marT="57785" marB="57785" anchor="t">
+                  <a:tcPr marL="57785" marR="57785" marT="57785" marB="57785">
                     <a:lnL w="12700" cap="flat" cmpd="sng" algn="ctr">
                       <a:solidFill>
                         <a:srgbClr val="CBCAC6"/>
@@ -4621,6 +4454,11 @@
                     </a:solidFill>
                   </a:tcPr>
                 </a:tc>
+                <a:extLst>
+                  <a:ext uri="{0D108BD9-81ED-4DB2-BD59-A6C34878D82A}">
+                    <a16:rowId xmlns:a16="http://schemas.microsoft.com/office/drawing/2014/main" val="10002"/>
+                  </a:ext>
+                </a:extLst>
               </a:tr>
               <a:tr h="590418">
                 <a:tc>
@@ -4628,7 +4466,7 @@
                     <a:bodyPr/>
                     <a:lstStyle/>
                     <a:p>
-                      <a:pPr indent="0" marL="0">
+                      <a:pPr marL="0" indent="0">
                         <a:lnSpc>
                           <a:spcPts val="1820"/>
                         </a:lnSpc>
@@ -4652,7 +4490,7 @@
                       </a:endParaRPr>
                     </a:p>
                   </a:txBody>
-                  <a:tcPr marL="57785" marR="57785" marT="57785" marB="57785" anchor="t">
+                  <a:tcPr marL="57785" marR="57785" marT="57785" marB="57785">
                     <a:lnL w="12700" cap="flat" cmpd="sng" algn="ctr">
                       <a:solidFill>
                         <a:srgbClr val="C4C3BE"/>
@@ -4696,7 +4534,7 @@
                     <a:bodyPr/>
                     <a:lstStyle/>
                     <a:p>
-                      <a:pPr indent="0" marL="0">
+                      <a:pPr marL="0" indent="0">
                         <a:lnSpc>
                           <a:spcPts val="1820"/>
                         </a:lnSpc>
@@ -4720,7 +4558,7 @@
                       </a:endParaRPr>
                     </a:p>
                   </a:txBody>
-                  <a:tcPr marL="57785" marR="57785" marT="57785" marB="57785" anchor="t">
+                  <a:tcPr marL="57785" marR="57785" marT="57785" marB="57785">
                     <a:lnL w="12700" cap="flat" cmpd="sng" algn="ctr">
                       <a:solidFill>
                         <a:srgbClr val="C4C3BE"/>
@@ -4764,7 +4602,7 @@
                     <a:bodyPr/>
                     <a:lstStyle/>
                     <a:p>
-                      <a:pPr indent="0" marL="0">
+                      <a:pPr marL="0" indent="0">
                         <a:lnSpc>
                           <a:spcPts val="1820"/>
                         </a:lnSpc>
@@ -4788,7 +4626,7 @@
                       </a:endParaRPr>
                     </a:p>
                   </a:txBody>
-                  <a:tcPr marL="57785" marR="57785" marT="57785" marB="57785" anchor="t">
+                  <a:tcPr marL="57785" marR="57785" marT="57785" marB="57785">
                     <a:lnL w="12700" cap="flat" cmpd="sng" algn="ctr">
                       <a:solidFill>
                         <a:srgbClr val="C4C3BE"/>
@@ -4832,7 +4670,7 @@
                     <a:bodyPr/>
                     <a:lstStyle/>
                     <a:p>
-                      <a:pPr indent="0" marL="0">
+                      <a:pPr marL="0" indent="0">
                         <a:lnSpc>
                           <a:spcPts val="1820"/>
                         </a:lnSpc>
@@ -4856,7 +4694,7 @@
                       </a:endParaRPr>
                     </a:p>
                   </a:txBody>
-                  <a:tcPr marL="57785" marR="57785" marT="57785" marB="57785" anchor="t">
+                  <a:tcPr marL="57785" marR="57785" marT="57785" marB="57785">
                     <a:lnL w="12700" cap="flat" cmpd="sng" algn="ctr">
                       <a:solidFill>
                         <a:srgbClr val="C4C3BE"/>
@@ -4895,6 +4733,11 @@
                     </a:lnB>
                   </a:tcPr>
                 </a:tc>
+                <a:extLst>
+                  <a:ext uri="{0D108BD9-81ED-4DB2-BD59-A6C34878D82A}">
+                    <a16:rowId xmlns:a16="http://schemas.microsoft.com/office/drawing/2014/main" val="10003"/>
+                  </a:ext>
+                </a:extLst>
               </a:tr>
               <a:tr h="590418">
                 <a:tc>
@@ -4902,7 +4745,7 @@
                     <a:bodyPr/>
                     <a:lstStyle/>
                     <a:p>
-                      <a:pPr indent="0" marL="0">
+                      <a:pPr marL="0" indent="0">
                         <a:lnSpc>
                           <a:spcPts val="1820"/>
                         </a:lnSpc>
@@ -4926,7 +4769,7 @@
                       </a:endParaRPr>
                     </a:p>
                   </a:txBody>
-                  <a:tcPr marL="57785" marR="57785" marT="57785" marB="57785" anchor="t">
+                  <a:tcPr marL="57785" marR="57785" marT="57785" marB="57785">
                     <a:lnL w="12700" cap="flat" cmpd="sng" algn="ctr">
                       <a:solidFill>
                         <a:srgbClr val="C4C3BE"/>
@@ -4973,7 +4816,7 @@
                     <a:bodyPr/>
                     <a:lstStyle/>
                     <a:p>
-                      <a:pPr indent="0" marL="0">
+                      <a:pPr marL="0" indent="0">
                         <a:lnSpc>
                           <a:spcPts val="1820"/>
                         </a:lnSpc>
@@ -4997,7 +4840,7 @@
                       </a:endParaRPr>
                     </a:p>
                   </a:txBody>
-                  <a:tcPr marL="57785" marR="57785" marT="57785" marB="57785" anchor="t">
+                  <a:tcPr marL="57785" marR="57785" marT="57785" marB="57785">
                     <a:lnL w="12700" cap="flat" cmpd="sng" algn="ctr">
                       <a:solidFill>
                         <a:srgbClr val="CBCAC6"/>
@@ -5044,7 +4887,7 @@
                     <a:bodyPr/>
                     <a:lstStyle/>
                     <a:p>
-                      <a:pPr indent="0" marL="0">
+                      <a:pPr marL="0" indent="0">
                         <a:lnSpc>
                           <a:spcPts val="1820"/>
                         </a:lnSpc>
@@ -5068,7 +4911,7 @@
                       </a:endParaRPr>
                     </a:p>
                   </a:txBody>
-                  <a:tcPr marL="57785" marR="57785" marT="57785" marB="57785" anchor="t">
+                  <a:tcPr marL="57785" marR="57785" marT="57785" marB="57785">
                     <a:lnL w="12700" cap="flat" cmpd="sng" algn="ctr">
                       <a:solidFill>
                         <a:srgbClr val="CBCAC6"/>
@@ -5115,7 +4958,7 @@
                     <a:bodyPr/>
                     <a:lstStyle/>
                     <a:p>
-                      <a:pPr indent="0" marL="0">
+                      <a:pPr marL="0" indent="0">
                         <a:lnSpc>
                           <a:spcPts val="1820"/>
                         </a:lnSpc>
@@ -5139,7 +4982,7 @@
                       </a:endParaRPr>
                     </a:p>
                   </a:txBody>
-                  <a:tcPr marL="57785" marR="57785" marT="57785" marB="57785" anchor="t">
+                  <a:tcPr marL="57785" marR="57785" marT="57785" marB="57785">
                     <a:lnL w="12700" cap="flat" cmpd="sng" algn="ctr">
                       <a:solidFill>
                         <a:srgbClr val="CBCAC6"/>
@@ -5181,6 +5024,11 @@
                     </a:solidFill>
                   </a:tcPr>
                 </a:tc>
+                <a:extLst>
+                  <a:ext uri="{0D108BD9-81ED-4DB2-BD59-A6C34878D82A}">
+                    <a16:rowId xmlns:a16="http://schemas.microsoft.com/office/drawing/2014/main" val="10004"/>
+                  </a:ext>
+                </a:extLst>
               </a:tr>
             </a:tbl>
           </a:graphicData>
@@ -5209,7 +5057,7 @@
           </a:bodyPr>
           <a:lstStyle/>
           <a:p>
-            <a:pPr algn="l" indent="0" marL="0">
+            <a:pPr marL="0" indent="0" algn="l">
               <a:lnSpc>
                 <a:spcPts val="1680"/>
               </a:lnSpc>
@@ -5246,6 +5094,7 @@
         <a:solidFill>
           <a:srgbClr val="F6F4EE"/>
         </a:solidFill>
+        <a:effectLst/>
       </p:bgPr>
     </p:bg>
     <p:spTree>
@@ -5285,14 +5134,14 @@
           </a:bodyPr>
           <a:lstStyle/>
           <a:p>
-            <a:pPr algn="l" indent="0" marL="0">
+            <a:pPr marL="0" indent="0" algn="l">
               <a:lnSpc>
                 <a:spcPts val="1680"/>
               </a:lnSpc>
               <a:buNone/>
             </a:pPr>
             <a:r>
-              <a:rPr lang="en-US" sz="1200" b="1" spc="100" kern="0" dirty="0">
+              <a:rPr lang="en-US" sz="1200" b="1" kern="0" spc="100" dirty="0">
                 <a:solidFill>
                   <a:srgbClr val="B5481A"/>
                 </a:solidFill>
@@ -5309,7 +5158,9 @@
       <p:sp>
         <p:nvSpPr>
           <p:cNvPr id="3" name="Text 1"/>
-          <p:cNvSpPr/>
+          <p:cNvSpPr>
+            <a:spLocks noGrp="1"/>
+          </p:cNvSpPr>
           <p:nvPr>
             <p:ph type="title"/>
           </p:nvPr>
@@ -5331,7 +5182,7 @@
           </a:bodyPr>
           <a:lstStyle/>
           <a:p>
-            <a:pPr algn="l" indent="0" marL="0">
+            <a:pPr marL="0" indent="0" algn="l">
               <a:lnSpc>
                 <a:spcPts val="3680"/>
               </a:lnSpc>
@@ -5375,7 +5226,7 @@
           </a:bodyPr>
           <a:lstStyle/>
           <a:p>
-            <a:pPr algn="l" indent="0" marL="0">
+            <a:pPr marL="0" indent="0" algn="l">
               <a:lnSpc>
                 <a:spcPts val="2160"/>
               </a:lnSpc>
@@ -5419,7 +5270,7 @@
           </a:bodyPr>
           <a:lstStyle/>
           <a:p>
-            <a:pPr algn="l" marL="175768" indent="-175768">
+            <a:pPr marL="175768" indent="-175768" algn="l">
               <a:lnSpc>
                 <a:spcPts val="2100"/>
               </a:lnSpc>
@@ -5440,7 +5291,7 @@
             <a:endParaRPr lang="en-US" sz="1400" dirty="0"/>
           </a:p>
           <a:p>
-            <a:pPr algn="l" marL="175768" indent="-175768">
+            <a:pPr marL="175768" indent="-175768" algn="l">
               <a:lnSpc>
                 <a:spcPts val="2100"/>
               </a:lnSpc>
@@ -5461,7 +5312,7 @@
             <a:endParaRPr lang="en-US" sz="1400" dirty="0"/>
           </a:p>
           <a:p>
-            <a:pPr algn="l" marL="175768" indent="-175768">
+            <a:pPr marL="175768" indent="-175768" algn="l">
               <a:lnSpc>
                 <a:spcPts val="2100"/>
               </a:lnSpc>
@@ -5482,7 +5333,7 @@
             <a:endParaRPr lang="en-US" sz="1400" dirty="0"/>
           </a:p>
           <a:p>
-            <a:pPr algn="l" marL="175768" indent="-175768">
+            <a:pPr marL="175768" indent="-175768" algn="l">
               <a:lnSpc>
                 <a:spcPts val="2100"/>
               </a:lnSpc>
@@ -5503,7 +5354,7 @@
             <a:endParaRPr lang="en-US" sz="1400" dirty="0"/>
           </a:p>
           <a:p>
-            <a:pPr algn="l" marL="175768" indent="-175768">
+            <a:pPr marL="175768" indent="-175768" algn="l">
               <a:lnSpc>
                 <a:spcPts val="2100"/>
               </a:lnSpc>
@@ -5524,7 +5375,7 @@
             <a:endParaRPr lang="en-US" sz="1400" dirty="0"/>
           </a:p>
           <a:p>
-            <a:pPr algn="l" marL="175768" indent="-175768">
+            <a:pPr marL="175768" indent="-175768" algn="l">
               <a:lnSpc>
                 <a:spcPts val="2100"/>
               </a:lnSpc>
@@ -5596,7 +5447,7 @@
           </a:bodyPr>
           <a:lstStyle/>
           <a:p>
-            <a:pPr algn="l" indent="0" marL="0">
+            <a:pPr marL="0" indent="0" algn="l">
               <a:lnSpc>
                 <a:spcPts val="4800"/>
               </a:lnSpc>
@@ -5640,7 +5491,7 @@
           </a:bodyPr>
           <a:lstStyle/>
           <a:p>
-            <a:pPr algn="l" indent="0" marL="0">
+            <a:pPr marL="0" indent="0" algn="l">
               <a:lnSpc>
                 <a:spcPts val="1890"/>
               </a:lnSpc>
@@ -5711,7 +5562,7 @@
           </a:bodyPr>
           <a:lstStyle/>
           <a:p>
-            <a:pPr algn="l" indent="0" marL="0">
+            <a:pPr marL="0" indent="0" algn="l">
               <a:lnSpc>
                 <a:spcPts val="4800"/>
               </a:lnSpc>
@@ -5755,7 +5606,7 @@
           </a:bodyPr>
           <a:lstStyle/>
           <a:p>
-            <a:pPr algn="l" indent="0" marL="0">
+            <a:pPr marL="0" indent="0" algn="l">
               <a:lnSpc>
                 <a:spcPts val="1890"/>
               </a:lnSpc>
@@ -5792,6 +5643,7 @@
         <a:solidFill>
           <a:srgbClr val="F6F4EE"/>
         </a:solidFill>
+        <a:effectLst/>
       </p:bgPr>
     </p:bg>
     <p:spTree>
@@ -5831,14 +5683,14 @@
           </a:bodyPr>
           <a:lstStyle/>
           <a:p>
-            <a:pPr algn="l" indent="0" marL="0">
+            <a:pPr marL="0" indent="0" algn="l">
               <a:lnSpc>
                 <a:spcPts val="1680"/>
               </a:lnSpc>
               <a:buNone/>
             </a:pPr>
             <a:r>
-              <a:rPr lang="en-US" sz="1200" b="1" spc="100" kern="0" dirty="0">
+              <a:rPr lang="en-US" sz="1200" b="1" kern="0" spc="100" dirty="0">
                 <a:solidFill>
                   <a:srgbClr val="B5481A"/>
                 </a:solidFill>
@@ -5855,7 +5707,9 @@
       <p:sp>
         <p:nvSpPr>
           <p:cNvPr id="3" name="Text 1"/>
-          <p:cNvSpPr/>
+          <p:cNvSpPr>
+            <a:spLocks noGrp="1"/>
+          </p:cNvSpPr>
           <p:nvPr>
             <p:ph type="title"/>
           </p:nvPr>
@@ -5877,7 +5731,7 @@
           </a:bodyPr>
           <a:lstStyle/>
           <a:p>
-            <a:pPr algn="l" indent="0" marL="0">
+            <a:pPr marL="0" indent="0" algn="l">
               <a:lnSpc>
                 <a:spcPts val="3680"/>
               </a:lnSpc>
@@ -5948,7 +5802,7 @@
           </a:bodyPr>
           <a:lstStyle/>
           <a:p>
-            <a:pPr algn="l" indent="0" marL="0">
+            <a:pPr marL="0" indent="0" algn="l">
               <a:lnSpc>
                 <a:spcPts val="1680"/>
               </a:lnSpc>
@@ -5992,7 +5846,7 @@
           </a:bodyPr>
           <a:lstStyle/>
           <a:p>
-            <a:pPr algn="l" indent="0" marL="0">
+            <a:pPr marL="0" indent="0" algn="l">
               <a:lnSpc>
                 <a:spcPts val="1800"/>
               </a:lnSpc>
@@ -6036,7 +5890,7 @@
           </a:bodyPr>
           <a:lstStyle/>
           <a:p>
-            <a:pPr algn="l" indent="0" marL="0">
+            <a:pPr marL="0" indent="0" algn="l">
               <a:lnSpc>
                 <a:spcPts val="1680"/>
               </a:lnSpc>
@@ -6107,7 +5961,7 @@
           </a:bodyPr>
           <a:lstStyle/>
           <a:p>
-            <a:pPr algn="l" indent="0" marL="0">
+            <a:pPr marL="0" indent="0" algn="l">
               <a:lnSpc>
                 <a:spcPts val="1680"/>
               </a:lnSpc>
@@ -6151,7 +6005,7 @@
           </a:bodyPr>
           <a:lstStyle/>
           <a:p>
-            <a:pPr algn="l" indent="0" marL="0">
+            <a:pPr marL="0" indent="0" algn="l">
               <a:lnSpc>
                 <a:spcPts val="1800"/>
               </a:lnSpc>
@@ -6195,7 +6049,7 @@
           </a:bodyPr>
           <a:lstStyle/>
           <a:p>
-            <a:pPr algn="l" indent="0" marL="0">
+            <a:pPr marL="0" indent="0" algn="l">
               <a:lnSpc>
                 <a:spcPts val="1680"/>
               </a:lnSpc>
@@ -6266,7 +6120,7 @@
           </a:bodyPr>
           <a:lstStyle/>
           <a:p>
-            <a:pPr algn="l" indent="0" marL="0">
+            <a:pPr marL="0" indent="0" algn="l">
               <a:lnSpc>
                 <a:spcPts val="1680"/>
               </a:lnSpc>
@@ -6310,7 +6164,7 @@
           </a:bodyPr>
           <a:lstStyle/>
           <a:p>
-            <a:pPr algn="l" indent="0" marL="0">
+            <a:pPr marL="0" indent="0" algn="l">
               <a:lnSpc>
                 <a:spcPts val="1800"/>
               </a:lnSpc>
@@ -6354,7 +6208,7 @@
           </a:bodyPr>
           <a:lstStyle/>
           <a:p>
-            <a:pPr algn="l" indent="0" marL="0">
+            <a:pPr marL="0" indent="0" algn="l">
               <a:lnSpc>
                 <a:spcPts val="1680"/>
               </a:lnSpc>
@@ -6425,7 +6279,7 @@
           </a:bodyPr>
           <a:lstStyle/>
           <a:p>
-            <a:pPr algn="l" indent="0" marL="0">
+            <a:pPr marL="0" indent="0" algn="l">
               <a:lnSpc>
                 <a:spcPts val="1680"/>
               </a:lnSpc>
@@ -6469,7 +6323,7 @@
           </a:bodyPr>
           <a:lstStyle/>
           <a:p>
-            <a:pPr algn="l" indent="0" marL="0">
+            <a:pPr marL="0" indent="0" algn="l">
               <a:lnSpc>
                 <a:spcPts val="1800"/>
               </a:lnSpc>
@@ -6513,7 +6367,7 @@
           </a:bodyPr>
           <a:lstStyle/>
           <a:p>
-            <a:pPr algn="l" indent="0" marL="0">
+            <a:pPr marL="0" indent="0" algn="l">
               <a:lnSpc>
                 <a:spcPts val="1680"/>
               </a:lnSpc>
@@ -6584,7 +6438,7 @@
           </a:bodyPr>
           <a:lstStyle/>
           <a:p>
-            <a:pPr algn="l" indent="0" marL="0">
+            <a:pPr marL="0" indent="0" algn="l">
               <a:lnSpc>
                 <a:spcPts val="1680"/>
               </a:lnSpc>
@@ -6628,7 +6482,7 @@
           </a:bodyPr>
           <a:lstStyle/>
           <a:p>
-            <a:pPr algn="l" indent="0" marL="0">
+            <a:pPr marL="0" indent="0" algn="l">
               <a:lnSpc>
                 <a:spcPts val="1800"/>
               </a:lnSpc>
@@ -6672,7 +6526,7 @@
           </a:bodyPr>
           <a:lstStyle/>
           <a:p>
-            <a:pPr algn="l" indent="0" marL="0">
+            <a:pPr marL="0" indent="0" algn="l">
               <a:lnSpc>
                 <a:spcPts val="1680"/>
               </a:lnSpc>
@@ -6716,7 +6570,7 @@
           </a:bodyPr>
           <a:lstStyle/>
           <a:p>
-            <a:pPr algn="l" indent="0" marL="0">
+            <a:pPr marL="0" indent="0" algn="l">
               <a:lnSpc>
                 <a:spcPts val="2175"/>
               </a:lnSpc>
@@ -6753,6 +6607,7 @@
         <a:solidFill>
           <a:srgbClr val="14213D"/>
         </a:solidFill>
+        <a:effectLst/>
       </p:bgPr>
     </p:bg>
     <p:spTree>
@@ -6792,14 +6647,14 @@
           </a:bodyPr>
           <a:lstStyle/>
           <a:p>
-            <a:pPr algn="l" indent="0" marL="0">
+            <a:pPr marL="0" indent="0" algn="l">
               <a:lnSpc>
                 <a:spcPts val="1680"/>
               </a:lnSpc>
               <a:buNone/>
             </a:pPr>
             <a:r>
-              <a:rPr lang="en-US" sz="1200" b="1" spc="100" kern="0" dirty="0">
+              <a:rPr lang="en-US" sz="1200" b="1" kern="0" spc="100" dirty="0">
                 <a:solidFill>
                   <a:srgbClr val="F2A65A"/>
                 </a:solidFill>
@@ -6816,7 +6671,9 @@
       <p:sp>
         <p:nvSpPr>
           <p:cNvPr id="3" name="Text 1"/>
-          <p:cNvSpPr/>
+          <p:cNvSpPr>
+            <a:spLocks noGrp="1"/>
+          </p:cNvSpPr>
           <p:nvPr>
             <p:ph type="title"/>
           </p:nvPr>
@@ -6838,7 +6695,7 @@
           </a:bodyPr>
           <a:lstStyle/>
           <a:p>
-            <a:pPr algn="l" indent="0" marL="0">
+            <a:pPr marL="0" indent="0" algn="l">
               <a:lnSpc>
                 <a:spcPts val="3680"/>
               </a:lnSpc>
@@ -6882,7 +6739,7 @@
           </a:bodyPr>
           <a:lstStyle/>
           <a:p>
-            <a:pPr algn="l" marL="182880" indent="-182880">
+            <a:pPr marL="182880" indent="-182880" algn="l">
               <a:lnSpc>
                 <a:spcPts val="2250"/>
               </a:lnSpc>
@@ -6903,7 +6760,7 @@
             <a:endParaRPr lang="en-US" sz="1500" dirty="0"/>
           </a:p>
           <a:p>
-            <a:pPr algn="l" marL="182880" indent="-182880">
+            <a:pPr marL="182880" indent="-182880" algn="l">
               <a:lnSpc>
                 <a:spcPts val="2250"/>
               </a:lnSpc>
@@ -6924,7 +6781,7 @@
             <a:endParaRPr lang="en-US" sz="1500" dirty="0"/>
           </a:p>
           <a:p>
-            <a:pPr algn="l" marL="182880" indent="-182880">
+            <a:pPr marL="182880" indent="-182880" algn="l">
               <a:lnSpc>
                 <a:spcPts val="2250"/>
               </a:lnSpc>
@@ -6991,7 +6848,7 @@
           </a:bodyPr>
           <a:lstStyle/>
           <a:p>
-            <a:pPr algn="l" indent="0" marL="0">
+            <a:pPr marL="0" indent="0" algn="l">
               <a:lnSpc>
                 <a:spcPts val="2160"/>
               </a:lnSpc>
@@ -7035,7 +6892,7 @@
           </a:bodyPr>
           <a:lstStyle/>
           <a:p>
-            <a:pPr algn="l" marL="175768" indent="-175768">
+            <a:pPr marL="175768" indent="-175768" algn="l">
               <a:lnSpc>
                 <a:spcPts val="2100"/>
               </a:lnSpc>
@@ -7056,7 +6913,7 @@
             <a:endParaRPr lang="en-US" sz="1400" dirty="0"/>
           </a:p>
           <a:p>
-            <a:pPr algn="l" marL="175768" indent="-175768">
+            <a:pPr marL="175768" indent="-175768" algn="l">
               <a:lnSpc>
                 <a:spcPts val="2100"/>
               </a:lnSpc>
@@ -7077,7 +6934,7 @@
             <a:endParaRPr lang="en-US" sz="1400" dirty="0"/>
           </a:p>
           <a:p>
-            <a:pPr algn="l" marL="175768" indent="-175768">
+            <a:pPr marL="175768" indent="-175768" algn="l">
               <a:lnSpc>
                 <a:spcPts val="2100"/>
               </a:lnSpc>
@@ -7098,7 +6955,7 @@
             <a:endParaRPr lang="en-US" sz="1400" dirty="0"/>
           </a:p>
           <a:p>
-            <a:pPr algn="l" marL="175768" indent="-175768">
+            <a:pPr marL="175768" indent="-175768" algn="l">
               <a:lnSpc>
                 <a:spcPts val="2100"/>
               </a:lnSpc>
@@ -7119,7 +6976,7 @@
             <a:endParaRPr lang="en-US" sz="1400" dirty="0"/>
           </a:p>
           <a:p>
-            <a:pPr algn="l" marL="175768" indent="-175768">
+            <a:pPr marL="175768" indent="-175768" algn="l">
               <a:lnSpc>
                 <a:spcPts val="2100"/>
               </a:lnSpc>
@@ -7164,7 +7021,7 @@
           </a:bodyPr>
           <a:lstStyle/>
           <a:p>
-            <a:pPr algn="l" indent="0" marL="0">
+            <a:pPr marL="0" indent="0" algn="l">
               <a:lnSpc>
                 <a:spcPts val="1680"/>
               </a:lnSpc>
@@ -7481,4 +7338,299 @@
   <a:objectDefaults/>
   <a:extraClrSchemeLst/>
 </a:theme>
+</file>
+
+<file path=ppt/theme/theme2.xml><?xml version="1.0" encoding="utf-8"?>
+<a:theme xmlns:a="http://schemas.openxmlformats.org/drawingml/2006/main" name="Office Theme">
+  <a:themeElements>
+    <a:clrScheme name="Office">
+      <a:dk1>
+        <a:sysClr val="windowText" lastClr="000000"/>
+      </a:dk1>
+      <a:lt1>
+        <a:sysClr val="window" lastClr="FFFFFF"/>
+      </a:lt1>
+      <a:dk2>
+        <a:srgbClr val="44546A"/>
+      </a:dk2>
+      <a:lt2>
+        <a:srgbClr val="E7E6E6"/>
+      </a:lt2>
+      <a:accent1>
+        <a:srgbClr val="4472C4"/>
+      </a:accent1>
+      <a:accent2>
+        <a:srgbClr val="ED7D31"/>
+      </a:accent2>
+      <a:accent3>
+        <a:srgbClr val="A5A5A5"/>
+      </a:accent3>
+      <a:accent4>
+        <a:srgbClr val="FFC000"/>
+      </a:accent4>
+      <a:accent5>
+        <a:srgbClr val="5B9BD5"/>
+      </a:accent5>
+      <a:accent6>
+        <a:srgbClr val="70AD47"/>
+      </a:accent6>
+      <a:hlink>
+        <a:srgbClr val="0563C1"/>
+      </a:hlink>
+      <a:folHlink>
+        <a:srgbClr val="954F72"/>
+      </a:folHlink>
+    </a:clrScheme>
+    <a:fontScheme name="Office">
+      <a:majorFont>
+        <a:latin typeface="Calibri Light" panose="020F0302020204030204"/>
+        <a:ea typeface=""/>
+        <a:cs typeface=""/>
+        <a:font script="Jpan" typeface="游ゴシック Light"/>
+        <a:font script="Hang" typeface="맑은 고딕"/>
+        <a:font script="Hans" typeface="等线 Light"/>
+        <a:font script="Hant" typeface="新細明體"/>
+        <a:font script="Arab" typeface="Times New Roman"/>
+        <a:font script="Hebr" typeface="Times New Roman"/>
+        <a:font script="Thai" typeface="Angsana New"/>
+        <a:font script="Ethi" typeface="Nyala"/>
+        <a:font script="Beng" typeface="Vrinda"/>
+        <a:font script="Gujr" typeface="Shruti"/>
+        <a:font script="Khmr" typeface="MoolBoran"/>
+        <a:font script="Knda" typeface="Tunga"/>
+        <a:font script="Guru" typeface="Raavi"/>
+        <a:font script="Cans" typeface="Euphemia"/>
+        <a:font script="Cher" typeface="Plantagenet Cherokee"/>
+        <a:font script="Yiii" typeface="Microsoft Yi Baiti"/>
+        <a:font script="Tibt" typeface="Microsoft Himalaya"/>
+        <a:font script="Thaa" typeface="MV Boli"/>
+        <a:font script="Deva" typeface="Mangal"/>
+        <a:font script="Telu" typeface="Gautami"/>
+        <a:font script="Taml" typeface="Latha"/>
+        <a:font script="Syrc" typeface="Estrangelo Edessa"/>
+        <a:font script="Orya" typeface="Kalinga"/>
+        <a:font script="Mlym" typeface="Kartika"/>
+        <a:font script="Laoo" typeface="DokChampa"/>
+        <a:font script="Sinh" typeface="Iskoola Pota"/>
+        <a:font script="Mong" typeface="Mongolian Baiti"/>
+        <a:font script="Viet" typeface="Times New Roman"/>
+        <a:font script="Uigh" typeface="Microsoft Uighur"/>
+        <a:font script="Geor" typeface="Sylfaen"/>
+        <a:font script="Armn" typeface="Arial"/>
+        <a:font script="Bugi" typeface="Leelawadee UI"/>
+        <a:font script="Bopo" typeface="Microsoft JhengHei"/>
+        <a:font script="Java" typeface="Javanese Text"/>
+        <a:font script="Lisu" typeface="Segoe UI"/>
+        <a:font script="Mymr" typeface="Myanmar Text"/>
+        <a:font script="Nkoo" typeface="Ebrima"/>
+        <a:font script="Olck" typeface="Nirmala UI"/>
+        <a:font script="Osma" typeface="Ebrima"/>
+        <a:font script="Phag" typeface="Phagspa"/>
+        <a:font script="Syrn" typeface="Estrangelo Edessa"/>
+        <a:font script="Syrj" typeface="Estrangelo Edessa"/>
+        <a:font script="Syre" typeface="Estrangelo Edessa"/>
+        <a:font script="Sora" typeface="Nirmala UI"/>
+        <a:font script="Tale" typeface="Microsoft Tai Le"/>
+        <a:font script="Talu" typeface="Microsoft New Tai Lue"/>
+        <a:font script="Tfng" typeface="Ebrima"/>
+      </a:majorFont>
+      <a:minorFont>
+        <a:latin typeface="Calibri" panose="020F0502020204030204"/>
+        <a:ea typeface=""/>
+        <a:cs typeface=""/>
+        <a:font script="Jpan" typeface="游ゴシック"/>
+        <a:font script="Hang" typeface="맑은 고딕"/>
+        <a:font script="Hans" typeface="等线"/>
+        <a:font script="Hant" typeface="新細明體"/>
+        <a:font script="Arab" typeface="Arial"/>
+        <a:font script="Hebr" typeface="Arial"/>
+        <a:font script="Thai" typeface="Cordia New"/>
+        <a:font script="Ethi" typeface="Nyala"/>
+        <a:font script="Beng" typeface="Vrinda"/>
+        <a:font script="Gujr" typeface="Shruti"/>
+        <a:font script="Khmr" typeface="DaunPenh"/>
+        <a:font script="Knda" typeface="Tunga"/>
+        <a:font script="Guru" typeface="Raavi"/>
+        <a:font script="Cans" typeface="Euphemia"/>
+        <a:font script="Cher" typeface="Plantagenet Cherokee"/>
+        <a:font script="Yiii" typeface="Microsoft Yi Baiti"/>
+        <a:font script="Tibt" typeface="Microsoft Himalaya"/>
+        <a:font script="Thaa" typeface="MV Boli"/>
+        <a:font script="Deva" typeface="Mangal"/>
+        <a:font script="Telu" typeface="Gautami"/>
+        <a:font script="Taml" typeface="Latha"/>
+        <a:font script="Syrc" typeface="Estrangelo Edessa"/>
+        <a:font script="Orya" typeface="Kalinga"/>
+        <a:font script="Mlym" typeface="Kartika"/>
+        <a:font script="Laoo" typeface="DokChampa"/>
+        <a:font script="Sinh" typeface="Iskoola Pota"/>
+        <a:font script="Mong" typeface="Mongolian Baiti"/>
+        <a:font script="Viet" typeface="Arial"/>
+        <a:font script="Uigh" typeface="Microsoft Uighur"/>
+        <a:font script="Geor" typeface="Sylfaen"/>
+        <a:font script="Armn" typeface="Arial"/>
+        <a:font script="Bugi" typeface="Leelawadee UI"/>
+        <a:font script="Bopo" typeface="Microsoft JhengHei"/>
+        <a:font script="Java" typeface="Javanese Text"/>
+        <a:font script="Lisu" typeface="Segoe UI"/>
+        <a:font script="Mymr" typeface="Myanmar Text"/>
+        <a:font script="Nkoo" typeface="Ebrima"/>
+        <a:font script="Olck" typeface="Nirmala UI"/>
+        <a:font script="Osma" typeface="Ebrima"/>
+        <a:font script="Phag" typeface="Phagspa"/>
+        <a:font script="Syrn" typeface="Estrangelo Edessa"/>
+        <a:font script="Syrj" typeface="Estrangelo Edessa"/>
+        <a:font script="Syre" typeface="Estrangelo Edessa"/>
+        <a:font script="Sora" typeface="Nirmala UI"/>
+        <a:font script="Tale" typeface="Microsoft Tai Le"/>
+        <a:font script="Talu" typeface="Microsoft New Tai Lue"/>
+        <a:font script="Tfng" typeface="Ebrima"/>
+      </a:minorFont>
+    </a:fontScheme>
+    <a:fmtScheme name="Office">
+      <a:fillStyleLst>
+        <a:solidFill>
+          <a:schemeClr val="phClr"/>
+        </a:solidFill>
+        <a:gradFill rotWithShape="1">
+          <a:gsLst>
+            <a:gs pos="0">
+              <a:schemeClr val="phClr">
+                <a:lumMod val="110000"/>
+                <a:satMod val="105000"/>
+                <a:tint val="67000"/>
+              </a:schemeClr>
+            </a:gs>
+            <a:gs pos="50000">
+              <a:schemeClr val="phClr">
+                <a:lumMod val="105000"/>
+                <a:satMod val="103000"/>
+                <a:tint val="73000"/>
+              </a:schemeClr>
+            </a:gs>
+            <a:gs pos="100000">
+              <a:schemeClr val="phClr">
+                <a:lumMod val="105000"/>
+                <a:satMod val="109000"/>
+                <a:tint val="81000"/>
+              </a:schemeClr>
+            </a:gs>
+          </a:gsLst>
+          <a:lin ang="5400000" scaled="0"/>
+        </a:gradFill>
+        <a:gradFill rotWithShape="1">
+          <a:gsLst>
+            <a:gs pos="0">
+              <a:schemeClr val="phClr">
+                <a:satMod val="103000"/>
+                <a:lumMod val="102000"/>
+                <a:tint val="94000"/>
+              </a:schemeClr>
+            </a:gs>
+            <a:gs pos="50000">
+              <a:schemeClr val="phClr">
+                <a:satMod val="110000"/>
+                <a:lumMod val="100000"/>
+                <a:shade val="100000"/>
+              </a:schemeClr>
+            </a:gs>
+            <a:gs pos="100000">
+              <a:schemeClr val="phClr">
+                <a:lumMod val="99000"/>
+                <a:satMod val="120000"/>
+                <a:shade val="78000"/>
+              </a:schemeClr>
+            </a:gs>
+          </a:gsLst>
+          <a:lin ang="5400000" scaled="0"/>
+        </a:gradFill>
+      </a:fillStyleLst>
+      <a:lnStyleLst>
+        <a:ln w="6350" cap="flat" cmpd="sng" algn="ctr">
+          <a:solidFill>
+            <a:schemeClr val="phClr"/>
+          </a:solidFill>
+          <a:prstDash val="solid"/>
+          <a:miter lim="800000"/>
+        </a:ln>
+        <a:ln w="12700" cap="flat" cmpd="sng" algn="ctr">
+          <a:solidFill>
+            <a:schemeClr val="phClr"/>
+          </a:solidFill>
+          <a:prstDash val="solid"/>
+          <a:miter lim="800000"/>
+        </a:ln>
+        <a:ln w="19050" cap="flat" cmpd="sng" algn="ctr">
+          <a:solidFill>
+            <a:schemeClr val="phClr"/>
+          </a:solidFill>
+          <a:prstDash val="solid"/>
+          <a:miter lim="800000"/>
+        </a:ln>
+      </a:lnStyleLst>
+      <a:effectStyleLst>
+        <a:effectStyle>
+          <a:effectLst/>
+        </a:effectStyle>
+        <a:effectStyle>
+          <a:effectLst/>
+        </a:effectStyle>
+        <a:effectStyle>
+          <a:effectLst>
+            <a:outerShdw blurRad="57150" dist="19050" dir="5400000" algn="ctr" rotWithShape="0">
+              <a:srgbClr val="000000">
+                <a:alpha val="63000"/>
+              </a:srgbClr>
+            </a:outerShdw>
+          </a:effectLst>
+        </a:effectStyle>
+      </a:effectStyleLst>
+      <a:bgFillStyleLst>
+        <a:solidFill>
+          <a:schemeClr val="phClr"/>
+        </a:solidFill>
+        <a:solidFill>
+          <a:schemeClr val="phClr">
+            <a:tint val="95000"/>
+            <a:satMod val="170000"/>
+          </a:schemeClr>
+        </a:solidFill>
+        <a:gradFill rotWithShape="1">
+          <a:gsLst>
+            <a:gs pos="0">
+              <a:schemeClr val="phClr">
+                <a:tint val="93000"/>
+                <a:satMod val="150000"/>
+                <a:shade val="98000"/>
+                <a:lumMod val="102000"/>
+              </a:schemeClr>
+            </a:gs>
+            <a:gs pos="50000">
+              <a:schemeClr val="phClr">
+                <a:tint val="98000"/>
+                <a:satMod val="130000"/>
+                <a:shade val="90000"/>
+                <a:lumMod val="103000"/>
+              </a:schemeClr>
+            </a:gs>
+            <a:gs pos="100000">
+              <a:schemeClr val="phClr">
+                <a:shade val="63000"/>
+                <a:satMod val="120000"/>
+              </a:schemeClr>
+            </a:gs>
+          </a:gsLst>
+          <a:lin ang="5400000" scaled="0"/>
+        </a:gradFill>
+      </a:bgFillStyleLst>
+    </a:fmtScheme>
+  </a:themeElements>
+  <a:objectDefaults/>
+  <a:extraClrSchemeLst/>
+  <a:extLst>
+    <a:ext uri="{05A4C25C-085E-4340-85A3-A5531E510DB2}">
+      <thm15:themeFamily xmlns:thm15="http://schemas.microsoft.com/office/thememl/2012/main" name="Office Theme" id="{62F939B6-93AF-4DB8-9C6B-D6C7DFDC589F}" vid="{4A3C46E8-61CC-4603-A589-7422A47A8E4A}"/>
+    </a:ext>
+  </a:extLst>
+</a:theme>
 </file>
</xml_diff>